<commit_message>
chore(hygiene): strip appointing-party identifiers from the public MIT tree
GitHub must not name the channel customer; RT-001 stays OPEN and customer_go stays false.
</commit_message>
<xml_diff>
--- a/submission/03-presentation/aerobim_kt2.pptx
+++ b/submission/03-presentation/aerobim_kt2.pptx
@@ -8854,7 +8854,7 @@
                 </a:solidFill>
                 <a:latin typeface="Aptos"/>
               </a:rPr>
-              <a:t>Countable-срез открытого набора; не корпус Самолёта.</a:t>
+              <a:t>Countable-срез открытого набора; не корпус заказчика.</a:t>
             </a:r>
           </a:p>
         </p:txBody>
@@ -10439,7 +10439,7 @@
                 </a:solidFill>
                 <a:latin typeface="Aptos"/>
               </a:rPr>
-              <a:t>Комплект Самолёта и его хеш</a:t>
+              <a:t>Комплект заказчика канала и его хеш</a:t>
             </a:r>
             <a:br/>
             <a:r>

</xml_diff>